<commit_message>
fix(presentation): cinq fiches, une par kiosque assisté
La consigne d'origine parlait d'écrire cinq fois son nom puis de remettre
« cette fiche » au singulier ; la diapo illustrait donc une fiche unique à cinq
lignes. C'est bien cinq fiches distinctes, une remise à chaque kiosque, cinq
dépôts dans l'urne.

La conséquence est ajoutée, parce qu'elle motive le parcours et ne se déduit
pas de la mécanique seule : cinq fiches déposées, cinq chances au tirage.

Co-Authored-By: Claude Opus 5 <noreply@anthropic.com>
Claude-Session: https://claude.ai/code/session_01Pwjz3VzeEknRuHTVSBE4Pa
</commit_message>
<xml_diff>
--- a/outils/affiches/presentation-testing-event.pptx
+++ b/outils/affiches/presentation-testing-event.pptx
@@ -5677,7 +5677,7 @@
                 </a:solidFill>
                 <a:latin typeface="Barlow Condensed"/>
               </a:rPr>
-              <a:t>LE JEU — UNE FICHE, UNE URNE, TROIS GAGNANTS</a:t>
+              <a:t>LE JEU — CINQ FICHES, UNE URNE, TROIS GAGNANTS</a:t>
             </a:r>
           </a:p>
         </p:txBody>
@@ -5914,7 +5914,7 @@
                 </a:solidFill>
                 <a:latin typeface="Barlow Condensed"/>
               </a:rPr>
-              <a:t>Une fiche</a:t>
+              <a:t>Une fiche par kiosque</a:t>
             </a:r>
           </a:p>
           <a:p>
@@ -5930,7 +5930,7 @@
                 </a:solidFill>
                 <a:latin typeface="Barlow"/>
               </a:rPr>
-              <a:t>Vous recevez une fiche en début d'après-midi.</a:t>
+              <a:t>À chaque kiosque auquel vous assistez, une fiche vous est remise.</a:t>
             </a:r>
           </a:p>
         </p:txBody>
@@ -6098,7 +6098,7 @@
                 </a:solidFill>
                 <a:latin typeface="Barlow Condensed"/>
               </a:rPr>
-              <a:t>Cinq lignes</a:t>
+              <a:t>Vos nom et prénom</a:t>
             </a:r>
           </a:p>
           <a:p>
@@ -6114,7 +6114,7 @@
                 </a:solidFill>
                 <a:latin typeface="Barlow"/>
               </a:rPr>
-              <a:t>À chaque kiosque, vous y inscrivez vos nom et prénom et le numéro du kiosque — cinq fois dans l'après-midi.</a:t>
+              <a:t>Vous y inscrivez vos nom et prénom, et le numéro du kiosque.</a:t>
             </a:r>
           </a:p>
         </p:txBody>
@@ -6298,7 +6298,7 @@
                 </a:solidFill>
                 <a:latin typeface="Barlow"/>
               </a:rPr>
-              <a:t>En fin de parcours, vous déposez votre fiche dans l'urne prévue à cet effet.</a:t>
+              <a:t>Vous déposez la fiche dans l'urne. Cinq kiosques dans l'après-midi, donc cinq fiches.</a:t>
             </a:r>
           </a:p>
         </p:txBody>
@@ -6544,6 +6544,15 @@
                 <a:spcPct val="100000"/>
               </a:lnSpc>
             </a:pPr>
+            <a:r>
+              <a:rPr sz="1300" b="1">
+                <a:solidFill>
+                  <a:srgbClr val="006A6A"/>
+                </a:solidFill>
+                <a:latin typeface="Barlow"/>
+              </a:rPr>
+              <a:t>Cinq fiches déposées, cinq chances au tirage. </a:t>
+            </a:r>
             <a:r>
               <a:rPr sz="1300" b="0">
                 <a:solidFill>

</xml_diff>